<commit_message>
ai in practice update
</commit_message>
<xml_diff>
--- a/resources/AI-in-Practice-Presentation-Schweinberger.pptx
+++ b/resources/AI-in-Practice-Presentation-Schweinberger.pptx
@@ -176,7 +176,7 @@
   <pc:docChgLst>
     <pc:chgData name="Martin Schweinberger" userId="90c3b6fdff4c5443" providerId="LiveId" clId="{16B467C6-3D5B-4F2A-A3D4-D5D9DBF197BE}"/>
     <pc:docChg chg="undo custSel addSld delSld modSld sldOrd modSection">
-      <pc:chgData name="Martin Schweinberger" userId="90c3b6fdff4c5443" providerId="LiveId" clId="{16B467C6-3D5B-4F2A-A3D4-D5D9DBF197BE}" dt="2026-08-17T11:11:40.781" v="4286" actId="113"/>
+      <pc:chgData name="Martin Schweinberger" userId="90c3b6fdff4c5443" providerId="LiveId" clId="{16B467C6-3D5B-4F2A-A3D4-D5D9DBF197BE}" dt="2026-08-17T22:46:15.708" v="4309" actId="20577"/>
       <pc:docMkLst>
         <pc:docMk/>
       </pc:docMkLst>
@@ -787,7 +787,7 @@
         </pc:cxnChg>
       </pc:sldChg>
       <pc:sldChg chg="addSp delSp modSp add mod ord modClrScheme chgLayout">
-        <pc:chgData name="Martin Schweinberger" userId="90c3b6fdff4c5443" providerId="LiveId" clId="{16B467C6-3D5B-4F2A-A3D4-D5D9DBF197BE}" dt="2026-08-17T11:10:07.341" v="4281" actId="313"/>
+        <pc:chgData name="Martin Schweinberger" userId="90c3b6fdff4c5443" providerId="LiveId" clId="{16B467C6-3D5B-4F2A-A3D4-D5D9DBF197BE}" dt="2026-08-17T22:46:15.708" v="4309" actId="20577"/>
         <pc:sldMkLst>
           <pc:docMk/>
           <pc:sldMk cId="3362732958" sldId="454"/>
@@ -801,7 +801,7 @@
           </ac:spMkLst>
         </pc:spChg>
         <pc:spChg chg="mod ord">
-          <ac:chgData name="Martin Schweinberger" userId="90c3b6fdff4c5443" providerId="LiveId" clId="{16B467C6-3D5B-4F2A-A3D4-D5D9DBF197BE}" dt="2026-08-17T11:04:22.829" v="4182" actId="6549"/>
+          <ac:chgData name="Martin Schweinberger" userId="90c3b6fdff4c5443" providerId="LiveId" clId="{16B467C6-3D5B-4F2A-A3D4-D5D9DBF197BE}" dt="2026-08-17T22:46:15.708" v="4309" actId="20577"/>
           <ac:spMkLst>
             <pc:docMk/>
             <pc:sldMk cId="3362732958" sldId="454"/>
@@ -1023,7 +1023,7 @@
           <a:p>
             <a:fld id="{412A36AD-C140-47B5-A0AA-2808AF1C1C9D}" type="datetimeFigureOut">
               <a:rPr lang="en-AU" smtClean="0"/>
-              <a:t>17/08/2026</a:t>
+              <a:t>18/08/2026</a:t>
             </a:fld>
             <a:endParaRPr lang="en-AU"/>
           </a:p>
@@ -1188,7 +1188,7 @@
           <a:p>
             <a:fld id="{2763829E-EB69-4A98-9D54-8D6822520B27}" type="datetimeFigureOut">
               <a:rPr lang="en-AU" smtClean="0"/>
-              <a:t>17/08/2026</a:t>
+              <a:t>18/08/2026</a:t>
             </a:fld>
             <a:endParaRPr lang="en-AU"/>
           </a:p>
@@ -27727,7 +27727,12 @@
             <p:ph sz="quarter" idx="10"/>
           </p:nvPr>
         </p:nvSpPr>
-        <p:spPr/>
+        <p:spPr>
+          <a:xfrm>
+            <a:off x="479424" y="2255224"/>
+            <a:ext cx="3587751" cy="4602776"/>
+          </a:xfrm>
+        </p:spPr>
         <p:txBody>
           <a:bodyPr/>
           <a:lstStyle/>
@@ -27750,8 +27755,13 @@
             </a:pPr>
             <a:r>
               <a:rPr lang="en-US" sz="1800" b="0" dirty="0"/>
-              <a:t>English linguistics, Philosophy, Psychology, Computer Science</a:t>
-            </a:r>
+              <a:t>English linguistics, Philosophy, Psychology, Computer Science/</a:t>
+            </a:r>
+            <a:r>
+              <a:rPr lang="en-US" sz="1800" b="0"/>
+              <a:t>Language Technology</a:t>
+            </a:r>
+            <a:endParaRPr lang="en-US" sz="1800" b="0" dirty="0"/>
           </a:p>
           <a:p>
             <a:pPr>
@@ -36216,6 +36226,15 @@
 </file>
 
 <file path=customXml/item1.xml><?xml version="1.0" encoding="utf-8"?>
+<?mso-contentType ?>
+<FormTemplates xmlns="http://schemas.microsoft.com/sharepoint/v3/contenttype/forms">
+  <Display>DocumentLibraryForm</Display>
+  <Edit>DocumentLibraryForm</Edit>
+  <New>DocumentLibraryForm</New>
+</FormTemplates>
+</file>
+
+<file path=customXml/item2.xml><?xml version="1.0" encoding="utf-8"?>
 <p:properties xmlns:p="http://schemas.microsoft.com/office/2006/metadata/properties" xmlns:xsi="http://www.w3.org/2001/XMLSchema-instance" xmlns:pc="http://schemas.microsoft.com/office/infopath/2007/PartnerControls">
   <documentManagement>
     <lcf76f155ced4ddcb4097134ff3c332f xmlns="d91a6f23-6c04-4099-84ef-dedc8cf6a590">
@@ -36225,15 +36244,6 @@
     <_Flow_SignoffStatus xmlns="d91a6f23-6c04-4099-84ef-dedc8cf6a590" xsi:nil="true"/>
   </documentManagement>
 </p:properties>
-</file>
-
-<file path=customXml/item2.xml><?xml version="1.0" encoding="utf-8"?>
-<?mso-contentType ?>
-<FormTemplates xmlns="http://schemas.microsoft.com/sharepoint/v3/contenttype/forms">
-  <Display>DocumentLibraryForm</Display>
-  <Edit>DocumentLibraryForm</Edit>
-  <New>DocumentLibraryForm</New>
-</FormTemplates>
 </file>
 
 <file path=customXml/item3.xml><?xml version="1.0" encoding="utf-8"?>
@@ -36504,6 +36514,14 @@
 </file>
 
 <file path=customXml/itemProps1.xml><?xml version="1.0" encoding="utf-8"?>
+<ds:datastoreItem xmlns:ds="http://schemas.openxmlformats.org/officeDocument/2006/customXml" ds:itemID="{732F4D4E-5CC3-44EF-852B-455B45EFC022}">
+  <ds:schemaRefs>
+    <ds:schemaRef ds:uri="http://schemas.microsoft.com/sharepoint/v3/contenttype/forms"/>
+  </ds:schemaRefs>
+</ds:datastoreItem>
+</file>
+
+<file path=customXml/itemProps2.xml><?xml version="1.0" encoding="utf-8"?>
 <ds:datastoreItem xmlns:ds="http://schemas.openxmlformats.org/officeDocument/2006/customXml" ds:itemID="{0BA6ACFB-BBAF-41D0-B45A-5E57454824E9}">
   <ds:schemaRefs>
     <ds:schemaRef ds:uri="http://schemas.microsoft.com/office/2006/metadata/properties"/>
@@ -36512,14 +36530,6 @@
     <ds:schemaRef ds:uri="94ba416d-00cf-4134-b72c-a9e48d8869bc"/>
     <ds:schemaRef ds:uri="d91a6f23-6c04-4099-84ef-dedc8cf6a590"/>
     <ds:schemaRef ds:uri="c313101e-b5c4-4115-8866-ae493b78d5ed"/>
-  </ds:schemaRefs>
-</ds:datastoreItem>
-</file>
-
-<file path=customXml/itemProps2.xml><?xml version="1.0" encoding="utf-8"?>
-<ds:datastoreItem xmlns:ds="http://schemas.openxmlformats.org/officeDocument/2006/customXml" ds:itemID="{732F4D4E-5CC3-44EF-852B-455B45EFC022}">
-  <ds:schemaRefs>
-    <ds:schemaRef ds:uri="http://schemas.microsoft.com/sharepoint/v3/contenttype/forms"/>
   </ds:schemaRefs>
 </ds:datastoreItem>
 </file>

</xml_diff>